<commit_message>
Simplify 과제 필요성 slide: replace right-top charts with text placeholders
Co-Authored-By: Claude Sonnet 5.5 <noreply@anthropic.com>
Claude-Session: https://claude.ai/code/session_01B7wj9GCcfJFYYu7dMdXsrV
</commit_message>
<xml_diff>
--- a/doc-mk/slides/problem-need-hetero-memory-v1.pptx
+++ b/doc-mk/slides/problem-need-hetero-memory-v1.pptx
@@ -5526,8 +5526,8 @@
         </p:nvSpPr>
         <p:spPr>
           <a:xfrm>
-            <a:off x="6336792" y="1572768"/>
-            <a:ext cx="5486400" cy="201168"/>
+            <a:off x="6473952" y="1874519"/>
+            <a:ext cx="5212080" cy="1280160"/>
           </a:xfrm>
           <a:prstGeom prst="rect">
             <a:avLst/>
@@ -5535,59 +5535,18 @@
           <a:noFill/>
         </p:spPr>
         <p:txBody>
-          <a:bodyPr wrap="square" anchor="t" lIns="45720" rIns="45720" tIns="27432" bIns="27432">
-            <a:spAutoFit/>
-          </a:bodyPr>
-          <a:lstStyle/>
-          <a:p>
-            <a:pPr algn="l">
-              <a:spcAft>
-                <a:spcPts val="200"/>
-              </a:spcAft>
-            </a:pPr>
-            <a:r>
-              <a:rPr sz="850" b="1">
-                <a:solidFill>
-                  <a:srgbClr val="595959"/>
-                </a:solidFill>
-                <a:latin typeface="맑은 고딕"/>
-                <a:ea typeface="맑은 고딕"/>
-                <a:cs typeface="맑은 고딕"/>
-              </a:rPr>
-              <a:t>(a) KV Offloading 유무 — 개선 배수(×), baseline = 1.0</a:t>
-            </a:r>
-          </a:p>
-        </p:txBody>
-      </p:sp>
-      <p:sp>
-        <p:nvSpPr>
-          <p:cNvPr id="32" name="TextBox 31"/>
-          <p:cNvSpPr txBox="1"/>
-          <p:nvPr/>
-        </p:nvSpPr>
-        <p:spPr>
-          <a:xfrm>
-            <a:off x="6336792" y="1764792"/>
-            <a:ext cx="2377440" cy="201168"/>
-          </a:xfrm>
-          <a:prstGeom prst="rect">
-            <a:avLst/>
-          </a:prstGeom>
-          <a:noFill/>
-        </p:spPr>
-        <p:txBody>
           <a:bodyPr wrap="square" anchor="ctr" lIns="45720" rIns="45720" tIns="27432" bIns="27432">
             <a:spAutoFit/>
           </a:bodyPr>
           <a:lstStyle/>
           <a:p>
-            <a:pPr algn="l">
+            <a:pPr algn="ctr">
               <a:spcAft>
-                <a:spcPts val="200"/>
+                <a:spcPts val="1400"/>
               </a:spcAft>
             </a:pPr>
             <a:r>
-              <a:rPr sz="800" b="0">
+              <a:rPr sz="1800" b="0">
                 <a:solidFill>
                   <a:srgbClr val="000000"/>
                 </a:solidFill>
@@ -5595,84 +5554,10 @@
                 <a:ea typeface="맑은 고딕"/>
                 <a:cs typeface="맑은 고딕"/>
               </a:rPr>
-              <a:t>Baseline: GPU 메모리만 사용 (vLLM)</a:t>
-            </a:r>
-          </a:p>
-        </p:txBody>
-      </p:sp>
-      <p:sp>
-        <p:nvSpPr>
-          <p:cNvPr id="33" name="Rectangle 32"/>
-          <p:cNvSpPr/>
-          <p:nvPr/>
-        </p:nvSpPr>
-        <p:spPr>
-          <a:xfrm>
-            <a:off x="8714232" y="1783080"/>
-            <a:ext cx="160020" cy="155448"/>
-          </a:xfrm>
-          <a:prstGeom prst="rect">
-            <a:avLst/>
-          </a:prstGeom>
-          <a:solidFill>
-            <a:srgbClr val="7F7F7F"/>
-          </a:solidFill>
-          <a:ln>
-            <a:noFill/>
-          </a:ln>
-          <a:effectLst/>
-        </p:spPr>
-        <p:style>
-          <a:lnRef idx="1">
-            <a:schemeClr val="accent1"/>
-          </a:lnRef>
-          <a:fillRef idx="3">
-            <a:schemeClr val="accent1"/>
-          </a:fillRef>
-          <a:effectRef idx="2">
-            <a:schemeClr val="accent1"/>
-          </a:effectRef>
-          <a:fontRef idx="minor">
-            <a:schemeClr val="lt1"/>
-          </a:fontRef>
-        </p:style>
-        <p:txBody>
-          <a:bodyPr rtlCol="0" anchor="ctr"/>
-          <a:lstStyle/>
-          <a:p>
-            <a:pPr algn="ctr"/>
-          </a:p>
-        </p:txBody>
-      </p:sp>
-      <p:sp>
-        <p:nvSpPr>
-          <p:cNvPr id="34" name="TextBox 33"/>
-          <p:cNvSpPr txBox="1"/>
-          <p:nvPr/>
-        </p:nvSpPr>
-        <p:spPr>
-          <a:xfrm>
-            <a:off x="8901684" y="1755648"/>
-            <a:ext cx="1005840" cy="201168"/>
-          </a:xfrm>
-          <a:prstGeom prst="rect">
-            <a:avLst/>
-          </a:prstGeom>
-          <a:noFill/>
-        </p:spPr>
-        <p:txBody>
-          <a:bodyPr wrap="square" anchor="ctr" lIns="45720" rIns="45720" tIns="27432" bIns="27432">
-            <a:spAutoFit/>
-          </a:bodyPr>
-          <a:lstStyle/>
-          <a:p>
-            <a:pPr algn="l">
-              <a:spcAft>
-                <a:spcPts val="200"/>
-              </a:spcAft>
-            </a:pPr>
-            <a:r>
-              <a:rPr sz="850" b="1">
+              <a:t>Offloading 하는 경우 vs 안하는 경우 </a:t>
+            </a:r>
+            <a:r>
+              <a:rPr sz="1800" b="1">
                 <a:solidFill>
                   <a:srgbClr val="000000"/>
                 </a:solidFill>
@@ -5680,40 +5565,17 @@
                 <a:ea typeface="맑은 고딕"/>
                 <a:cs typeface="맑은 고딕"/>
               </a:rPr>
-              <a:t>1.0×</a:t>
-            </a:r>
-          </a:p>
-        </p:txBody>
-      </p:sp>
-      <p:sp>
-        <p:nvSpPr>
-          <p:cNvPr id="35" name="TextBox 34"/>
-          <p:cNvSpPr txBox="1"/>
-          <p:nvPr/>
-        </p:nvSpPr>
-        <p:spPr>
-          <a:xfrm>
-            <a:off x="6336792" y="1947672"/>
-            <a:ext cx="2377440" cy="201168"/>
-          </a:xfrm>
-          <a:prstGeom prst="rect">
-            <a:avLst/>
-          </a:prstGeom>
-          <a:noFill/>
-        </p:spPr>
-        <p:txBody>
-          <a:bodyPr wrap="square" anchor="ctr" lIns="45720" rIns="45720" tIns="27432" bIns="27432">
-            <a:spAutoFit/>
-          </a:bodyPr>
-          <a:lstStyle/>
-          <a:p>
-            <a:pPr algn="l">
+              <a:t>성능 차이</a:t>
+            </a:r>
+          </a:p>
+          <a:p>
+            <a:pPr algn="ctr">
               <a:spcAft>
                 <a:spcPts val="200"/>
               </a:spcAft>
             </a:pPr>
             <a:r>
-              <a:rPr sz="800" b="0">
+              <a:rPr sz="1800" b="1">
                 <a:solidFill>
                   <a:srgbClr val="000000"/>
                 </a:solidFill>
@@ -5721,943 +5583,14 @@
                 <a:ea typeface="맑은 고딕"/>
                 <a:cs typeface="맑은 고딕"/>
               </a:rPr>
-              <a:t>LMCache 처리율 @동일 TTFT ①</a:t>
-            </a:r>
-          </a:p>
-        </p:txBody>
-      </p:sp>
-      <p:sp>
-        <p:nvSpPr>
-          <p:cNvPr id="36" name="Rectangle 35"/>
-          <p:cNvSpPr/>
-          <p:nvPr/>
-        </p:nvSpPr>
-        <p:spPr>
-          <a:xfrm>
-            <a:off x="8714232" y="1965960"/>
-            <a:ext cx="368046" cy="155448"/>
-          </a:xfrm>
-          <a:prstGeom prst="rect">
-            <a:avLst/>
-          </a:prstGeom>
-          <a:solidFill>
-            <a:srgbClr val="9DC3E6"/>
-          </a:solidFill>
-          <a:ln>
-            <a:noFill/>
-          </a:ln>
-          <a:effectLst/>
-        </p:spPr>
-        <p:style>
-          <a:lnRef idx="1">
-            <a:schemeClr val="accent1"/>
-          </a:lnRef>
-          <a:fillRef idx="3">
-            <a:schemeClr val="accent1"/>
-          </a:fillRef>
-          <a:effectRef idx="2">
-            <a:schemeClr val="accent1"/>
-          </a:effectRef>
-          <a:fontRef idx="minor">
-            <a:schemeClr val="lt1"/>
-          </a:fontRef>
-        </p:style>
-        <p:txBody>
-          <a:bodyPr rtlCol="0" anchor="ctr"/>
-          <a:lstStyle/>
-          <a:p>
-            <a:pPr algn="ctr"/>
-          </a:p>
-        </p:txBody>
-      </p:sp>
-      <p:sp>
-        <p:nvSpPr>
-          <p:cNvPr id="37" name="Rectangle 36"/>
-          <p:cNvSpPr/>
-          <p:nvPr/>
-        </p:nvSpPr>
-        <p:spPr>
-          <a:xfrm>
-            <a:off x="9082278" y="1965960"/>
-            <a:ext cx="1872234" cy="155448"/>
-          </a:xfrm>
-          <a:prstGeom prst="rect">
-            <a:avLst/>
-          </a:prstGeom>
-          <a:solidFill>
-            <a:srgbClr val="2E75B6"/>
-          </a:solidFill>
-          <a:ln>
-            <a:noFill/>
-          </a:ln>
-          <a:effectLst/>
-        </p:spPr>
-        <p:style>
-          <a:lnRef idx="1">
-            <a:schemeClr val="accent1"/>
-          </a:lnRef>
-          <a:fillRef idx="3">
-            <a:schemeClr val="accent1"/>
-          </a:fillRef>
-          <a:effectRef idx="2">
-            <a:schemeClr val="accent1"/>
-          </a:effectRef>
-          <a:fontRef idx="minor">
-            <a:schemeClr val="lt1"/>
-          </a:fontRef>
-        </p:style>
-        <p:txBody>
-          <a:bodyPr rtlCol="0" anchor="ctr"/>
-          <a:lstStyle/>
-          <a:p>
-            <a:pPr algn="ctr"/>
-          </a:p>
-        </p:txBody>
-      </p:sp>
-      <p:sp>
-        <p:nvSpPr>
-          <p:cNvPr id="38" name="TextBox 37"/>
-          <p:cNvSpPr txBox="1"/>
-          <p:nvPr/>
-        </p:nvSpPr>
-        <p:spPr>
-          <a:xfrm>
-            <a:off x="10981944" y="1938528"/>
-            <a:ext cx="1005840" cy="201168"/>
-          </a:xfrm>
-          <a:prstGeom prst="rect">
-            <a:avLst/>
-          </a:prstGeom>
-          <a:noFill/>
-        </p:spPr>
-        <p:txBody>
-          <a:bodyPr wrap="square" anchor="ctr" lIns="45720" rIns="45720" tIns="27432" bIns="27432">
-            <a:spAutoFit/>
-          </a:bodyPr>
-          <a:lstStyle/>
-          <a:p>
-            <a:pPr algn="l">
-              <a:spcAft>
-                <a:spcPts val="200"/>
-              </a:spcAft>
-            </a:pPr>
-            <a:r>
-              <a:rPr sz="850" b="1">
-                <a:solidFill>
-                  <a:srgbClr val="000000"/>
-                </a:solidFill>
-                <a:latin typeface="맑은 고딕"/>
-                <a:ea typeface="맑은 고딕"/>
-                <a:cs typeface="맑은 고딕"/>
-              </a:rPr>
-              <a:t>2.3–14×</a:t>
-            </a:r>
-          </a:p>
-        </p:txBody>
-      </p:sp>
-      <p:sp>
-        <p:nvSpPr>
-          <p:cNvPr id="39" name="TextBox 38"/>
-          <p:cNvSpPr txBox="1"/>
-          <p:nvPr/>
-        </p:nvSpPr>
-        <p:spPr>
-          <a:xfrm>
-            <a:off x="6336792" y="2130552"/>
-            <a:ext cx="2377440" cy="201168"/>
-          </a:xfrm>
-          <a:prstGeom prst="rect">
-            <a:avLst/>
-          </a:prstGeom>
-          <a:noFill/>
-        </p:spPr>
-        <p:txBody>
-          <a:bodyPr wrap="square" anchor="ctr" lIns="45720" rIns="45720" tIns="27432" bIns="27432">
-            <a:spAutoFit/>
-          </a:bodyPr>
-          <a:lstStyle/>
-          <a:p>
-            <a:pPr algn="l">
-              <a:spcAft>
-                <a:spcPts val="200"/>
-              </a:spcAft>
-            </a:pPr>
-            <a:r>
-              <a:rPr sz="800" b="0">
-                <a:solidFill>
-                  <a:srgbClr val="000000"/>
-                </a:solidFill>
-                <a:latin typeface="맑은 고딕"/>
-                <a:ea typeface="맑은 고딕"/>
-                <a:cs typeface="맑은 고딕"/>
-              </a:rPr>
-              <a:t>LMCache TTFT 단축 (QPS=1) ①</a:t>
-            </a:r>
-          </a:p>
-        </p:txBody>
-      </p:sp>
-      <p:sp>
-        <p:nvSpPr>
-          <p:cNvPr id="40" name="Rectangle 39"/>
-          <p:cNvSpPr/>
-          <p:nvPr/>
-        </p:nvSpPr>
-        <p:spPr>
-          <a:xfrm>
-            <a:off x="8714232" y="2148840"/>
-            <a:ext cx="304038" cy="155448"/>
-          </a:xfrm>
-          <a:prstGeom prst="rect">
-            <a:avLst/>
-          </a:prstGeom>
-          <a:solidFill>
-            <a:srgbClr val="9DC3E6"/>
-          </a:solidFill>
-          <a:ln>
-            <a:noFill/>
-          </a:ln>
-          <a:effectLst/>
-        </p:spPr>
-        <p:style>
-          <a:lnRef idx="1">
-            <a:schemeClr val="accent1"/>
-          </a:lnRef>
-          <a:fillRef idx="3">
-            <a:schemeClr val="accent1"/>
-          </a:fillRef>
-          <a:effectRef idx="2">
-            <a:schemeClr val="accent1"/>
-          </a:effectRef>
-          <a:fontRef idx="minor">
-            <a:schemeClr val="lt1"/>
-          </a:fontRef>
-        </p:style>
-        <p:txBody>
-          <a:bodyPr rtlCol="0" anchor="ctr"/>
-          <a:lstStyle/>
-          <a:p>
-            <a:pPr algn="ctr"/>
-          </a:p>
-        </p:txBody>
-      </p:sp>
-      <p:sp>
-        <p:nvSpPr>
-          <p:cNvPr id="41" name="Rectangle 40"/>
-          <p:cNvSpPr/>
-          <p:nvPr/>
-        </p:nvSpPr>
-        <p:spPr>
-          <a:xfrm>
-            <a:off x="9018270" y="2148840"/>
-            <a:ext cx="992124" cy="155448"/>
-          </a:xfrm>
-          <a:prstGeom prst="rect">
-            <a:avLst/>
-          </a:prstGeom>
-          <a:solidFill>
-            <a:srgbClr val="2E75B6"/>
-          </a:solidFill>
-          <a:ln>
-            <a:noFill/>
-          </a:ln>
-          <a:effectLst/>
-        </p:spPr>
-        <p:style>
-          <a:lnRef idx="1">
-            <a:schemeClr val="accent1"/>
-          </a:lnRef>
-          <a:fillRef idx="3">
-            <a:schemeClr val="accent1"/>
-          </a:fillRef>
-          <a:effectRef idx="2">
-            <a:schemeClr val="accent1"/>
-          </a:effectRef>
-          <a:fontRef idx="minor">
-            <a:schemeClr val="lt1"/>
-          </a:fontRef>
-        </p:style>
-        <p:txBody>
-          <a:bodyPr rtlCol="0" anchor="ctr"/>
-          <a:lstStyle/>
-          <a:p>
-            <a:pPr algn="ctr"/>
-          </a:p>
-        </p:txBody>
-      </p:sp>
-      <p:sp>
-        <p:nvSpPr>
-          <p:cNvPr id="42" name="TextBox 41"/>
-          <p:cNvSpPr txBox="1"/>
-          <p:nvPr/>
-        </p:nvSpPr>
-        <p:spPr>
-          <a:xfrm>
-            <a:off x="10037826" y="2121408"/>
-            <a:ext cx="1005840" cy="201168"/>
-          </a:xfrm>
-          <a:prstGeom prst="rect">
-            <a:avLst/>
-          </a:prstGeom>
-          <a:noFill/>
-        </p:spPr>
-        <p:txBody>
-          <a:bodyPr wrap="square" anchor="ctr" lIns="45720" rIns="45720" tIns="27432" bIns="27432">
-            <a:spAutoFit/>
-          </a:bodyPr>
-          <a:lstStyle/>
-          <a:p>
-            <a:pPr algn="l">
-              <a:spcAft>
-                <a:spcPts val="200"/>
-              </a:spcAft>
-            </a:pPr>
-            <a:r>
-              <a:rPr sz="850" b="1">
-                <a:solidFill>
-                  <a:srgbClr val="000000"/>
-                </a:solidFill>
-                <a:latin typeface="맑은 고딕"/>
-                <a:ea typeface="맑은 고딕"/>
-                <a:cs typeface="맑은 고딕"/>
-              </a:rPr>
-              <a:t>1.9–8.1×</a:t>
-            </a:r>
-          </a:p>
-        </p:txBody>
-      </p:sp>
-      <p:sp>
-        <p:nvSpPr>
-          <p:cNvPr id="43" name="TextBox 42"/>
-          <p:cNvSpPr txBox="1"/>
-          <p:nvPr/>
-        </p:nvSpPr>
-        <p:spPr>
-          <a:xfrm>
-            <a:off x="6336792" y="2313432"/>
-            <a:ext cx="2377440" cy="201168"/>
-          </a:xfrm>
-          <a:prstGeom prst="rect">
-            <a:avLst/>
-          </a:prstGeom>
-          <a:noFill/>
-        </p:spPr>
-        <p:txBody>
-          <a:bodyPr wrap="square" anchor="ctr" lIns="45720" rIns="45720" tIns="27432" bIns="27432">
-            <a:spAutoFit/>
-          </a:bodyPr>
-          <a:lstStyle/>
-          <a:p>
-            <a:pPr algn="l">
-              <a:spcAft>
-                <a:spcPts val="200"/>
-              </a:spcAft>
-            </a:pPr>
-            <a:r>
-              <a:rPr sz="800" b="0">
-                <a:solidFill>
-                  <a:srgbClr val="000000"/>
-                </a:solidFill>
-                <a:latin typeface="맑은 고딕"/>
-                <a:ea typeface="맑은 고딕"/>
-                <a:cs typeface="맑은 고딕"/>
-              </a:rPr>
-              <a:t>Mooncake KV pool 요청 용량 (SLO 내) ②</a:t>
-            </a:r>
-          </a:p>
-        </p:txBody>
-      </p:sp>
-      <p:sp>
-        <p:nvSpPr>
-          <p:cNvPr id="44" name="Rectangle 43"/>
-          <p:cNvSpPr/>
-          <p:nvPr/>
-        </p:nvSpPr>
-        <p:spPr>
-          <a:xfrm>
-            <a:off x="8714232" y="2331720"/>
-            <a:ext cx="254431" cy="155448"/>
-          </a:xfrm>
-          <a:prstGeom prst="rect">
-            <a:avLst/>
-          </a:prstGeom>
-          <a:solidFill>
-            <a:srgbClr val="9DC3E6"/>
-          </a:solidFill>
-          <a:ln>
-            <a:noFill/>
-          </a:ln>
-          <a:effectLst/>
-        </p:spPr>
-        <p:style>
-          <a:lnRef idx="1">
-            <a:schemeClr val="accent1"/>
-          </a:lnRef>
-          <a:fillRef idx="3">
-            <a:schemeClr val="accent1"/>
-          </a:fillRef>
-          <a:effectRef idx="2">
-            <a:schemeClr val="accent1"/>
-          </a:effectRef>
-          <a:fontRef idx="minor">
-            <a:schemeClr val="lt1"/>
-          </a:fontRef>
-        </p:style>
-        <p:txBody>
-          <a:bodyPr rtlCol="0" anchor="ctr"/>
-          <a:lstStyle/>
-          <a:p>
-            <a:pPr algn="ctr"/>
-          </a:p>
-        </p:txBody>
-      </p:sp>
-      <p:sp>
-        <p:nvSpPr>
-          <p:cNvPr id="45" name="Rectangle 44"/>
-          <p:cNvSpPr/>
-          <p:nvPr/>
-        </p:nvSpPr>
-        <p:spPr>
-          <a:xfrm>
-            <a:off x="8968663" y="2331720"/>
-            <a:ext cx="702487" cy="155448"/>
-          </a:xfrm>
-          <a:prstGeom prst="rect">
-            <a:avLst/>
-          </a:prstGeom>
-          <a:solidFill>
-            <a:srgbClr val="2E75B6"/>
-          </a:solidFill>
-          <a:ln>
-            <a:noFill/>
-          </a:ln>
-          <a:effectLst/>
-        </p:spPr>
-        <p:style>
-          <a:lnRef idx="1">
-            <a:schemeClr val="accent1"/>
-          </a:lnRef>
-          <a:fillRef idx="3">
-            <a:schemeClr val="accent1"/>
-          </a:fillRef>
-          <a:effectRef idx="2">
-            <a:schemeClr val="accent1"/>
-          </a:effectRef>
-          <a:fontRef idx="minor">
-            <a:schemeClr val="lt1"/>
-          </a:fontRef>
-        </p:style>
-        <p:txBody>
-          <a:bodyPr rtlCol="0" anchor="ctr"/>
-          <a:lstStyle/>
-          <a:p>
-            <a:pPr algn="ctr"/>
-          </a:p>
-        </p:txBody>
-      </p:sp>
-      <p:sp>
-        <p:nvSpPr>
-          <p:cNvPr id="46" name="TextBox 45"/>
-          <p:cNvSpPr txBox="1"/>
-          <p:nvPr/>
-        </p:nvSpPr>
-        <p:spPr>
-          <a:xfrm>
-            <a:off x="9698583" y="2304288"/>
-            <a:ext cx="1005840" cy="201168"/>
-          </a:xfrm>
-          <a:prstGeom prst="rect">
-            <a:avLst/>
-          </a:prstGeom>
-          <a:noFill/>
-        </p:spPr>
-        <p:txBody>
-          <a:bodyPr wrap="square" anchor="ctr" lIns="45720" rIns="45720" tIns="27432" bIns="27432">
-            <a:spAutoFit/>
-          </a:bodyPr>
-          <a:lstStyle/>
-          <a:p>
-            <a:pPr algn="l">
-              <a:spcAft>
-                <a:spcPts val="200"/>
-              </a:spcAft>
-            </a:pPr>
-            <a:r>
-              <a:rPr sz="850" b="1">
-                <a:solidFill>
-                  <a:srgbClr val="000000"/>
-                </a:solidFill>
-                <a:latin typeface="맑은 고딕"/>
-                <a:ea typeface="맑은 고딕"/>
-                <a:cs typeface="맑은 고딕"/>
-              </a:rPr>
-              <a:t>1.59–5.98×</a:t>
-            </a:r>
-          </a:p>
-        </p:txBody>
-      </p:sp>
-      <p:sp>
-        <p:nvSpPr>
-          <p:cNvPr id="47" name="TextBox 46"/>
-          <p:cNvSpPr txBox="1"/>
-          <p:nvPr/>
-        </p:nvSpPr>
-        <p:spPr>
-          <a:xfrm>
-            <a:off x="6336792" y="2542032"/>
-            <a:ext cx="5486400" cy="201168"/>
-          </a:xfrm>
-          <a:prstGeom prst="rect">
-            <a:avLst/>
-          </a:prstGeom>
-          <a:noFill/>
-        </p:spPr>
-        <p:txBody>
-          <a:bodyPr wrap="square" anchor="t" lIns="45720" rIns="45720" tIns="27432" bIns="27432">
-            <a:spAutoFit/>
-          </a:bodyPr>
-          <a:lstStyle/>
-          <a:p>
-            <a:pPr algn="l">
-              <a:spcAft>
-                <a:spcPts val="200"/>
-              </a:spcAft>
-            </a:pPr>
-            <a:r>
-              <a:rPr sz="850" b="1">
-                <a:solidFill>
-                  <a:srgbClr val="595959"/>
-                </a:solidFill>
-                <a:latin typeface="맑은 고딕"/>
-                <a:ea typeface="맑은 고딕"/>
-                <a:cs typeface="맑은 고딕"/>
-              </a:rPr>
-              <a:t>(b) Scheduling 유무 — 처리량(steps/min), SWE-agent ③</a:t>
-            </a:r>
-          </a:p>
-        </p:txBody>
-      </p:sp>
-      <p:sp>
-        <p:nvSpPr>
-          <p:cNvPr id="48" name="TextBox 47"/>
-          <p:cNvSpPr txBox="1"/>
-          <p:nvPr/>
-        </p:nvSpPr>
-        <p:spPr>
-          <a:xfrm>
-            <a:off x="6336792" y="2734056"/>
-            <a:ext cx="2377440" cy="201168"/>
-          </a:xfrm>
-          <a:prstGeom prst="rect">
-            <a:avLst/>
-          </a:prstGeom>
-          <a:noFill/>
-        </p:spPr>
-        <p:txBody>
-          <a:bodyPr wrap="square" anchor="ctr" lIns="45720" rIns="45720" tIns="27432" bIns="27432">
-            <a:spAutoFit/>
-          </a:bodyPr>
-          <a:lstStyle/>
-          <a:p>
-            <a:pPr algn="l">
-              <a:spcAft>
-                <a:spcPts val="200"/>
-              </a:spcAft>
-            </a:pPr>
-            <a:r>
-              <a:rPr sz="800" b="0">
-                <a:solidFill>
-                  <a:srgbClr val="000000"/>
-                </a:solidFill>
-                <a:latin typeface="맑은 고딕"/>
-                <a:ea typeface="맑은 고딕"/>
-                <a:cs typeface="맑은 고딕"/>
-              </a:rPr>
-              <a:t>Baseline: 요청 단위 스케줄링 (vLLM)</a:t>
-            </a:r>
-          </a:p>
-        </p:txBody>
-      </p:sp>
-      <p:sp>
-        <p:nvSpPr>
-          <p:cNvPr id="49" name="Rectangle 48"/>
-          <p:cNvSpPr/>
-          <p:nvPr/>
-        </p:nvSpPr>
-        <p:spPr>
-          <a:xfrm>
-            <a:off x="8714232" y="2752344"/>
-            <a:ext cx="1250156" cy="155448"/>
-          </a:xfrm>
-          <a:prstGeom prst="rect">
-            <a:avLst/>
-          </a:prstGeom>
-          <a:solidFill>
-            <a:srgbClr val="7F7F7F"/>
-          </a:solidFill>
-          <a:ln>
-            <a:noFill/>
-          </a:ln>
-          <a:effectLst/>
-        </p:spPr>
-        <p:style>
-          <a:lnRef idx="1">
-            <a:schemeClr val="accent1"/>
-          </a:lnRef>
-          <a:fillRef idx="3">
-            <a:schemeClr val="accent1"/>
-          </a:fillRef>
-          <a:effectRef idx="2">
-            <a:schemeClr val="accent1"/>
-          </a:effectRef>
-          <a:fontRef idx="minor">
-            <a:schemeClr val="lt1"/>
-          </a:fontRef>
-        </p:style>
-        <p:txBody>
-          <a:bodyPr rtlCol="0" anchor="ctr"/>
-          <a:lstStyle/>
-          <a:p>
-            <a:pPr algn="ctr"/>
-          </a:p>
-        </p:txBody>
-      </p:sp>
-      <p:sp>
-        <p:nvSpPr>
-          <p:cNvPr id="50" name="TextBox 49"/>
-          <p:cNvSpPr txBox="1"/>
-          <p:nvPr/>
-        </p:nvSpPr>
-        <p:spPr>
-          <a:xfrm>
-            <a:off x="9991820" y="2724912"/>
-            <a:ext cx="1005840" cy="201168"/>
-          </a:xfrm>
-          <a:prstGeom prst="rect">
-            <a:avLst/>
-          </a:prstGeom>
-          <a:noFill/>
-        </p:spPr>
-        <p:txBody>
-          <a:bodyPr wrap="square" anchor="ctr" lIns="45720" rIns="45720" tIns="27432" bIns="27432">
-            <a:spAutoFit/>
-          </a:bodyPr>
-          <a:lstStyle/>
-          <a:p>
-            <a:pPr algn="l">
-              <a:spcAft>
-                <a:spcPts val="200"/>
-              </a:spcAft>
-            </a:pPr>
-            <a:r>
-              <a:rPr sz="850" b="1">
-                <a:solidFill>
-                  <a:srgbClr val="000000"/>
-                </a:solidFill>
-                <a:latin typeface="맑은 고딕"/>
-                <a:ea typeface="맑은 고딕"/>
-                <a:cs typeface="맑은 고딕"/>
-              </a:rPr>
-              <a:t>375</a:t>
-            </a:r>
-          </a:p>
-        </p:txBody>
-      </p:sp>
-      <p:sp>
-        <p:nvSpPr>
-          <p:cNvPr id="51" name="TextBox 50"/>
-          <p:cNvSpPr txBox="1"/>
-          <p:nvPr/>
-        </p:nvSpPr>
-        <p:spPr>
-          <a:xfrm>
-            <a:off x="6336792" y="2916936"/>
-            <a:ext cx="2377440" cy="201168"/>
-          </a:xfrm>
-          <a:prstGeom prst="rect">
-            <a:avLst/>
-          </a:prstGeom>
-          <a:noFill/>
-        </p:spPr>
-        <p:txBody>
-          <a:bodyPr wrap="square" anchor="ctr" lIns="45720" rIns="45720" tIns="27432" bIns="27432">
-            <a:spAutoFit/>
-          </a:bodyPr>
-          <a:lstStyle/>
-          <a:p>
-            <a:pPr algn="l">
-              <a:spcAft>
-                <a:spcPts val="200"/>
-              </a:spcAft>
-            </a:pPr>
-            <a:r>
-              <a:rPr sz="800" b="0">
-                <a:solidFill>
-                  <a:srgbClr val="000000"/>
-                </a:solidFill>
-                <a:latin typeface="맑은 고딕"/>
-                <a:ea typeface="맑은 고딕"/>
-                <a:cs typeface="맑은 고딕"/>
-              </a:rPr>
-              <a:t>+ 프로그램 인지 스케줄링 (로컬)</a:t>
-            </a:r>
-          </a:p>
-        </p:txBody>
-      </p:sp>
-      <p:sp>
-        <p:nvSpPr>
-          <p:cNvPr id="52" name="Rectangle 51"/>
-          <p:cNvSpPr/>
-          <p:nvPr/>
-        </p:nvSpPr>
-        <p:spPr>
-          <a:xfrm>
-            <a:off x="8714232" y="2935224"/>
-            <a:ext cx="2006917" cy="155448"/>
-          </a:xfrm>
-          <a:prstGeom prst="rect">
-            <a:avLst/>
-          </a:prstGeom>
-          <a:solidFill>
-            <a:srgbClr val="C55A11"/>
-          </a:solidFill>
-          <a:ln>
-            <a:noFill/>
-          </a:ln>
-          <a:effectLst/>
-        </p:spPr>
-        <p:style>
-          <a:lnRef idx="1">
-            <a:schemeClr val="accent1"/>
-          </a:lnRef>
-          <a:fillRef idx="3">
-            <a:schemeClr val="accent1"/>
-          </a:fillRef>
-          <a:effectRef idx="2">
-            <a:schemeClr val="accent1"/>
-          </a:effectRef>
-          <a:fontRef idx="minor">
-            <a:schemeClr val="lt1"/>
-          </a:fontRef>
-        </p:style>
-        <p:txBody>
-          <a:bodyPr rtlCol="0" anchor="ctr"/>
-          <a:lstStyle/>
-          <a:p>
-            <a:pPr algn="ctr"/>
-          </a:p>
-        </p:txBody>
-      </p:sp>
-      <p:sp>
-        <p:nvSpPr>
-          <p:cNvPr id="53" name="TextBox 52"/>
-          <p:cNvSpPr txBox="1"/>
-          <p:nvPr/>
-        </p:nvSpPr>
-        <p:spPr>
-          <a:xfrm>
-            <a:off x="10748581" y="2907792"/>
-            <a:ext cx="1005840" cy="201168"/>
-          </a:xfrm>
-          <a:prstGeom prst="rect">
-            <a:avLst/>
-          </a:prstGeom>
-          <a:noFill/>
-        </p:spPr>
-        <p:txBody>
-          <a:bodyPr wrap="square" anchor="ctr" lIns="45720" rIns="45720" tIns="27432" bIns="27432">
-            <a:spAutoFit/>
-          </a:bodyPr>
-          <a:lstStyle/>
-          <a:p>
-            <a:pPr algn="l">
-              <a:spcAft>
-                <a:spcPts val="200"/>
-              </a:spcAft>
-            </a:pPr>
-            <a:r>
-              <a:rPr sz="850" b="1">
-                <a:solidFill>
-                  <a:srgbClr val="000000"/>
-                </a:solidFill>
-                <a:latin typeface="맑은 고딕"/>
-                <a:ea typeface="맑은 고딕"/>
-                <a:cs typeface="맑은 고딕"/>
-              </a:rPr>
-              <a:t>602 (1.61×)</a:t>
-            </a:r>
-          </a:p>
-        </p:txBody>
-      </p:sp>
-      <p:sp>
-        <p:nvSpPr>
-          <p:cNvPr id="54" name="TextBox 53"/>
-          <p:cNvSpPr txBox="1"/>
-          <p:nvPr/>
-        </p:nvSpPr>
-        <p:spPr>
-          <a:xfrm>
-            <a:off x="6336792" y="3099816"/>
-            <a:ext cx="2377440" cy="201168"/>
-          </a:xfrm>
-          <a:prstGeom prst="rect">
-            <a:avLst/>
-          </a:prstGeom>
-          <a:noFill/>
-        </p:spPr>
-        <p:txBody>
-          <a:bodyPr wrap="square" anchor="ctr" lIns="45720" rIns="45720" tIns="27432" bIns="27432">
-            <a:spAutoFit/>
-          </a:bodyPr>
-          <a:lstStyle/>
-          <a:p>
-            <a:pPr algn="l">
-              <a:spcAft>
-                <a:spcPts val="200"/>
-              </a:spcAft>
-            </a:pPr>
-            <a:r>
-              <a:rPr sz="800" b="0">
-                <a:solidFill>
-                  <a:srgbClr val="000000"/>
-                </a:solidFill>
-                <a:latin typeface="맑은 고딕"/>
-                <a:ea typeface="맑은 고딕"/>
-                <a:cs typeface="맑은 고딕"/>
-              </a:rPr>
-              <a:t>+ 글로벌 대기열 (ThunderAgent)</a:t>
-            </a:r>
-          </a:p>
-        </p:txBody>
-      </p:sp>
-      <p:sp>
-        <p:nvSpPr>
-          <p:cNvPr id="55" name="Rectangle 54"/>
-          <p:cNvSpPr/>
-          <p:nvPr/>
-        </p:nvSpPr>
-        <p:spPr>
-          <a:xfrm>
-            <a:off x="8714232" y="3118104"/>
-            <a:ext cx="2240280" cy="155448"/>
-          </a:xfrm>
-          <a:prstGeom prst="rect">
-            <a:avLst/>
-          </a:prstGeom>
-          <a:solidFill>
-            <a:srgbClr val="C55A11"/>
-          </a:solidFill>
-          <a:ln>
-            <a:noFill/>
-          </a:ln>
-          <a:effectLst/>
-        </p:spPr>
-        <p:style>
-          <a:lnRef idx="1">
-            <a:schemeClr val="accent1"/>
-          </a:lnRef>
-          <a:fillRef idx="3">
-            <a:schemeClr val="accent1"/>
-          </a:fillRef>
-          <a:effectRef idx="2">
-            <a:schemeClr val="accent1"/>
-          </a:effectRef>
-          <a:fontRef idx="minor">
-            <a:schemeClr val="lt1"/>
-          </a:fontRef>
-        </p:style>
-        <p:txBody>
-          <a:bodyPr rtlCol="0" anchor="ctr"/>
-          <a:lstStyle/>
-          <a:p>
-            <a:pPr algn="ctr"/>
-          </a:p>
-        </p:txBody>
-      </p:sp>
-      <p:sp>
-        <p:nvSpPr>
-          <p:cNvPr id="56" name="TextBox 55"/>
-          <p:cNvSpPr txBox="1"/>
-          <p:nvPr/>
-        </p:nvSpPr>
-        <p:spPr>
-          <a:xfrm>
-            <a:off x="10981944" y="3090672"/>
-            <a:ext cx="1005840" cy="201168"/>
-          </a:xfrm>
-          <a:prstGeom prst="rect">
-            <a:avLst/>
-          </a:prstGeom>
-          <a:noFill/>
-        </p:spPr>
-        <p:txBody>
-          <a:bodyPr wrap="square" anchor="ctr" lIns="45720" rIns="45720" tIns="27432" bIns="27432">
-            <a:spAutoFit/>
-          </a:bodyPr>
-          <a:lstStyle/>
-          <a:p>
-            <a:pPr algn="l">
-              <a:spcAft>
-                <a:spcPts val="200"/>
-              </a:spcAft>
-            </a:pPr>
-            <a:r>
-              <a:rPr sz="850" b="1">
-                <a:solidFill>
-                  <a:srgbClr val="000000"/>
-                </a:solidFill>
-                <a:latin typeface="맑은 고딕"/>
-                <a:ea typeface="맑은 고딕"/>
-                <a:cs typeface="맑은 고딕"/>
-              </a:rPr>
-              <a:t>672 (1.79×)</a:t>
-            </a:r>
-          </a:p>
-        </p:txBody>
-      </p:sp>
-      <p:sp>
-        <p:nvSpPr>
-          <p:cNvPr id="57" name="TextBox 56"/>
-          <p:cNvSpPr txBox="1"/>
-          <p:nvPr/>
-        </p:nvSpPr>
-        <p:spPr>
-          <a:xfrm>
-            <a:off x="10222992" y="2560320"/>
-            <a:ext cx="1737360" cy="182880"/>
-          </a:xfrm>
-          <a:prstGeom prst="rect">
-            <a:avLst/>
-          </a:prstGeom>
-          <a:noFill/>
-        </p:spPr>
-        <p:txBody>
-          <a:bodyPr wrap="square" anchor="t" lIns="45720" rIns="45720" tIns="27432" bIns="27432">
-            <a:spAutoFit/>
-          </a:bodyPr>
-          <a:lstStyle/>
-          <a:p>
-            <a:pPr algn="r">
-              <a:spcAft>
-                <a:spcPts val="200"/>
-              </a:spcAft>
-            </a:pPr>
-            <a:r>
-              <a:rPr sz="800" b="1">
-                <a:solidFill>
-                  <a:srgbClr val="C55A11"/>
-                </a:solidFill>
-                <a:latin typeface="맑은 고딕"/>
-                <a:ea typeface="맑은 고딕"/>
-                <a:cs typeface="맑은 고딕"/>
-              </a:rPr>
-              <a:t>벤치마크 전반 1.48–3.58×</a:t>
-            </a:r>
-          </a:p>
-        </p:txBody>
-      </p:sp>
-      <p:sp>
-        <p:nvSpPr>
-          <p:cNvPr id="58" name="Rectangle 57"/>
+              <a:t>스케줄링 하는 경우 vs 안하는 경우 성능 차이</a:t>
+            </a:r>
+          </a:p>
+        </p:txBody>
+      </p:sp>
+      <p:sp>
+        <p:nvSpPr>
+          <p:cNvPr id="32" name="Rectangle 31"/>
           <p:cNvSpPr/>
           <p:nvPr/>
         </p:nvSpPr>
@@ -6702,7 +5635,7 @@
       </p:sp>
       <p:sp>
         <p:nvSpPr>
-          <p:cNvPr id="59" name="Rectangle 58"/>
+          <p:cNvPr id="33" name="Rectangle 32"/>
           <p:cNvSpPr/>
           <p:nvPr/>
         </p:nvSpPr>
@@ -6761,7 +5694,7 @@
       </p:sp>
       <p:sp>
         <p:nvSpPr>
-          <p:cNvPr id="60" name="TextBox 59"/>
+          <p:cNvPr id="34" name="TextBox 33"/>
           <p:cNvSpPr txBox="1"/>
           <p:nvPr/>
         </p:nvSpPr>
@@ -6802,7 +5735,7 @@
       </p:sp>
       <p:graphicFrame>
         <p:nvGraphicFramePr>
-          <p:cNvPr id="61" name="Table 60"/>
+          <p:cNvPr id="35" name="Table 34"/>
           <p:cNvGraphicFramePr>
             <a:graphicFrameLocks noGrp="1"/>
           </p:cNvGraphicFramePr>
@@ -7140,7 +6073,7 @@
                           <a:ea typeface="맑은 고딕"/>
                           <a:cs typeface="맑은 고딕"/>
                         </a:rPr>
-                        <a:t>&gt; $100B (Micron 전망) ④</a:t>
+                        <a:t>&gt; $100B (Micron 전망) ①</a:t>
                       </a:r>
                     </a:p>
                   </a:txBody>
@@ -7338,7 +6271,7 @@
                           <a:ea typeface="맑은 고딕"/>
                           <a:cs typeface="맑은 고딕"/>
                         </a:rPr>
-                        <a:t>수십 B$ (SK hynix 전망) ⑤</a:t>
+                        <a:t>수십 B$ (SK hynix 전망) ②</a:t>
                       </a:r>
                     </a:p>
                   </a:txBody>
@@ -7536,7 +6469,7 @@
                           <a:ea typeface="맑은 고딕"/>
                           <a:cs typeface="맑은 고딕"/>
                         </a:rPr>
-                        <a:t>약 $4–7B (범위 정의별 차이) ⑥</a:t>
+                        <a:t>약 $4–7B (범위 정의별 차이) ③</a:t>
                       </a:r>
                     </a:p>
                   </a:txBody>
@@ -7734,7 +6667,7 @@
                           <a:ea typeface="맑은 고딕"/>
                           <a:cs typeface="맑은 고딕"/>
                         </a:rPr>
-                        <a:t>$40–150B (Goldman, 2차 인용) ⑦</a:t>
+                        <a:t>$40–150B (Goldman, 2차 인용) ④</a:t>
                       </a:r>
                     </a:p>
                   </a:txBody>
@@ -7820,7 +6753,7 @@
       </p:graphicFrame>
       <p:sp>
         <p:nvSpPr>
-          <p:cNvPr id="62" name="Rectangle 61"/>
+          <p:cNvPr id="36" name="Rectangle 35"/>
           <p:cNvSpPr/>
           <p:nvPr/>
         </p:nvSpPr>
@@ -7865,7 +6798,7 @@
       </p:sp>
       <p:sp>
         <p:nvSpPr>
-          <p:cNvPr id="63" name="Rectangle 62"/>
+          <p:cNvPr id="37" name="Rectangle 36"/>
           <p:cNvSpPr/>
           <p:nvPr/>
         </p:nvSpPr>
@@ -7924,7 +6857,7 @@
       </p:sp>
       <p:sp>
         <p:nvSpPr>
-          <p:cNvPr id="64" name="TextBox 63"/>
+          <p:cNvPr id="38" name="TextBox 37"/>
           <p:cNvSpPr txBox="1"/>
           <p:nvPr/>
         </p:nvSpPr>
@@ -7965,7 +6898,7 @@
       </p:sp>
       <p:sp>
         <p:nvSpPr>
-          <p:cNvPr id="65" name="Rectangle 64"/>
+          <p:cNvPr id="39" name="Rectangle 38"/>
           <p:cNvSpPr/>
           <p:nvPr/>
         </p:nvSpPr>
@@ -8026,7 +6959,7 @@
       </p:sp>
       <p:cxnSp>
         <p:nvCxnSpPr>
-          <p:cNvPr id="66" name="Connector 65"/>
+          <p:cNvPr id="40" name="Connector 39"/>
           <p:cNvCxnSpPr/>
           <p:nvPr/>
         </p:nvCxnSpPr>
@@ -8063,7 +6996,7 @@
       </p:cxnSp>
       <p:sp>
         <p:nvSpPr>
-          <p:cNvPr id="67" name="Rectangle 66"/>
+          <p:cNvPr id="41" name="Rectangle 40"/>
           <p:cNvSpPr/>
           <p:nvPr/>
         </p:nvSpPr>
@@ -8143,7 +7076,7 @@
       </p:sp>
       <p:cxnSp>
         <p:nvCxnSpPr>
-          <p:cNvPr id="68" name="Connector 67"/>
+          <p:cNvPr id="42" name="Connector 41"/>
           <p:cNvCxnSpPr/>
           <p:nvPr/>
         </p:nvCxnSpPr>
@@ -8181,7 +7114,7 @@
       </p:cxnSp>
       <p:sp>
         <p:nvSpPr>
-          <p:cNvPr id="69" name="Rectangle 68"/>
+          <p:cNvPr id="43" name="Rectangle 42"/>
           <p:cNvSpPr/>
           <p:nvPr/>
         </p:nvSpPr>
@@ -8242,7 +7175,7 @@
       </p:sp>
       <p:sp>
         <p:nvSpPr>
-          <p:cNvPr id="70" name="Rectangle 69"/>
+          <p:cNvPr id="44" name="Rectangle 43"/>
           <p:cNvSpPr/>
           <p:nvPr/>
         </p:nvSpPr>
@@ -8303,7 +7236,7 @@
       </p:sp>
       <p:sp>
         <p:nvSpPr>
-          <p:cNvPr id="71" name="Rectangle 70"/>
+          <p:cNvPr id="45" name="Rectangle 44"/>
           <p:cNvSpPr/>
           <p:nvPr/>
         </p:nvSpPr>
@@ -8364,7 +7297,7 @@
       </p:sp>
       <p:sp>
         <p:nvSpPr>
-          <p:cNvPr id="72" name="Rectangle 71"/>
+          <p:cNvPr id="46" name="Rectangle 45"/>
           <p:cNvSpPr/>
           <p:nvPr/>
         </p:nvSpPr>
@@ -8426,7 +7359,7 @@
       </p:sp>
       <p:sp>
         <p:nvSpPr>
-          <p:cNvPr id="73" name="Rectangle 72"/>
+          <p:cNvPr id="47" name="Rectangle 46"/>
           <p:cNvSpPr/>
           <p:nvPr/>
         </p:nvSpPr>
@@ -8488,7 +7421,7 @@
       </p:sp>
       <p:sp>
         <p:nvSpPr>
-          <p:cNvPr id="74" name="Rectangle 73"/>
+          <p:cNvPr id="48" name="Rectangle 47"/>
           <p:cNvSpPr/>
           <p:nvPr/>
         </p:nvSpPr>
@@ -8550,7 +7483,7 @@
       </p:sp>
       <p:sp>
         <p:nvSpPr>
-          <p:cNvPr id="75" name="TextBox 74"/>
+          <p:cNvPr id="49" name="TextBox 48"/>
           <p:cNvSpPr txBox="1"/>
           <p:nvPr/>
         </p:nvSpPr>
@@ -8591,7 +7524,7 @@
       </p:sp>
       <p:sp>
         <p:nvSpPr>
-          <p:cNvPr id="76" name="TextBox 75"/>
+          <p:cNvPr id="50" name="TextBox 49"/>
           <p:cNvSpPr txBox="1"/>
           <p:nvPr/>
         </p:nvSpPr>
@@ -8632,7 +7565,7 @@
       </p:sp>
       <p:sp>
         <p:nvSpPr>
-          <p:cNvPr id="77" name="Rounded Rectangle 76"/>
+          <p:cNvPr id="51" name="Rounded Rectangle 50"/>
           <p:cNvSpPr/>
           <p:nvPr/>
         </p:nvSpPr>
@@ -8691,7 +7624,7 @@
       </p:sp>
       <p:sp>
         <p:nvSpPr>
-          <p:cNvPr id="78" name="TextBox 77"/>
+          <p:cNvPr id="52" name="TextBox 51"/>
           <p:cNvSpPr txBox="1"/>
           <p:nvPr/>
         </p:nvSpPr>
@@ -8725,7 +7658,7 @@
                 <a:ea typeface="맑은 고딕"/>
                 <a:cs typeface="맑은 고딕"/>
               </a:rPr>
-              <a:t>※ 효과 배수는 각 연구의 모델·워크로드·baseline 조건에서 측정한 값으로, 연구 간 직접 비교는 불가. 시장 전망은 출처·범위 정의별 편차가 큼(검증 전 공개 전망).</a:t>
+              <a:t>※ 시장 전망은 출처·범위 정의별 편차가 큼(검증 전 공개 전망).</a:t>
             </a:r>
           </a:p>
           <a:p>
@@ -8743,25 +7676,7 @@
                 <a:ea typeface="맑은 고딕"/>
                 <a:cs typeface="맑은 고딕"/>
               </a:rPr>
-              <a:t>① LMCache, arXiv:2510.09665 (단일 노드 CPU offload, 10K-token 멀티라운드 QA, baseline = GPU-only vLLM)  ② Mooncake, USENIX FAST'25 (Qin et al.), baseline 대비 유효 요청 용량 +59–498%  ③ ThunderAgent, arXiv:2602.13692 (v2) — 1.48–3.58× vs vLLM; 하단 막대는 부록 ablation(GLM-4.5-fp8, mini-SWEAgent, 2×H100, 144 programs)</a:t>
-            </a:r>
-          </a:p>
-          <a:p>
-            <a:pPr algn="l">
-              <a:spcAft>
-                <a:spcPts val="0"/>
-              </a:spcAft>
-            </a:pPr>
-            <a:r>
-              <a:rPr sz="650" b="0">
-                <a:solidFill>
-                  <a:srgbClr val="595959"/>
-                </a:solidFill>
-                <a:latin typeface="맑은 고딕"/>
-                <a:ea typeface="맑은 고딕"/>
-                <a:cs typeface="맑은 고딕"/>
-              </a:rPr>
-              <a:t>④ Micron FQ1'25 실적발표(2024 $16B → 2030 &gt; $100B, 회사 전망)  ⑤ SK hynix 전망, Tom's Hardware  ⑥ Mordor Intelligence·Business Research Co. 등(2030 약 $4–7B, 보수적 정의 기준)  ⑦ Goldman Sachs 추정의 2차 인용(404k Research Substack), 원문 미확인; 샘플 2026 하반기·소규모 상용 2027–28 (OSCOO)</a:t>
+              <a:t>① Micron FQ1'25 실적발표(2024 $16B → 2030 &gt; $100B, 회사 전망)  ② SK hynix 전망, Tom's Hardware  ③ Mordor Intelligence·Business Research Co. 등(2030 약 $4–7B, 보수적 정의 기준)  ④ Goldman Sachs 추정의 2차 인용(404k Research Substack), 원문 미확인; 샘플 2026 하반기·소규모 상용 2027–28 (OSCOO)</a:t>
             </a:r>
           </a:p>
         </p:txBody>

</xml_diff>

<commit_message>
Right-top panel: two baseline-vs-optimized comparisons (offloading, scheduling) with environment and sources
Co-Authored-By: Claude Sonnet 5.5 <noreply@anthropic.com>
Claude-Session: https://claude.ai/code/session_01B7wj9GCcfJFYYu7dMdXsrV
</commit_message>
<xml_diff>
--- a/doc-mk/slides/problem-need-hetero-memory-v1.pptx
+++ b/doc-mk/slides/problem-need-hetero-memory-v1.pptx
@@ -5526,8 +5526,8 @@
         </p:nvSpPr>
         <p:spPr>
           <a:xfrm>
-            <a:off x="6473952" y="1874519"/>
-            <a:ext cx="5212080" cy="1280160"/>
+            <a:off x="6291072" y="1591056"/>
+            <a:ext cx="2743200" cy="329184"/>
           </a:xfrm>
           <a:prstGeom prst="rect">
             <a:avLst/>
@@ -5535,18 +5535,191 @@
           <a:noFill/>
         </p:spPr>
         <p:txBody>
-          <a:bodyPr wrap="square" anchor="ctr" lIns="45720" rIns="45720" tIns="27432" bIns="27432">
+          <a:bodyPr wrap="square" anchor="t" lIns="45720" rIns="45720" tIns="27432" bIns="27432">
             <a:spAutoFit/>
           </a:bodyPr>
           <a:lstStyle/>
           <a:p>
+            <a:pPr algn="l">
+              <a:spcAft>
+                <a:spcPts val="200"/>
+              </a:spcAft>
+            </a:pPr>
+            <a:r>
+              <a:rPr sz="950" b="1">
+                <a:solidFill>
+                  <a:srgbClr val="404040"/>
+                </a:solidFill>
+                <a:latin typeface="맑은 고딕"/>
+                <a:ea typeface="맑은 고딕"/>
+                <a:cs typeface="맑은 고딕"/>
+              </a:rPr>
+              <a:t>① KV Offloading 유무: 처리량 (tok/s) ⑤</a:t>
+            </a:r>
+          </a:p>
+        </p:txBody>
+      </p:sp>
+      <p:sp>
+        <p:nvSpPr>
+          <p:cNvPr id="32" name="Rectangle 31"/>
+          <p:cNvSpPr/>
+          <p:nvPr/>
+        </p:nvSpPr>
+        <p:spPr>
+          <a:xfrm>
+            <a:off x="6565392" y="2670048"/>
+            <a:ext cx="640080" cy="73152"/>
+          </a:xfrm>
+          <a:prstGeom prst="rect">
+            <a:avLst/>
+          </a:prstGeom>
+          <a:solidFill>
+            <a:srgbClr val="7F7F7F"/>
+          </a:solidFill>
+          <a:ln>
+            <a:noFill/>
+          </a:ln>
+          <a:effectLst/>
+        </p:spPr>
+        <p:style>
+          <a:lnRef idx="1">
+            <a:schemeClr val="accent1"/>
+          </a:lnRef>
+          <a:fillRef idx="3">
+            <a:schemeClr val="accent1"/>
+          </a:fillRef>
+          <a:effectRef idx="2">
+            <a:schemeClr val="accent1"/>
+          </a:effectRef>
+          <a:fontRef idx="minor">
+            <a:schemeClr val="lt1"/>
+          </a:fontRef>
+        </p:style>
+        <p:txBody>
+          <a:bodyPr rtlCol="0" anchor="ctr"/>
+          <a:lstStyle/>
+          <a:p>
+            <a:pPr algn="ctr"/>
+          </a:p>
+        </p:txBody>
+      </p:sp>
+      <p:sp>
+        <p:nvSpPr>
+          <p:cNvPr id="33" name="Rectangle 32"/>
+          <p:cNvSpPr/>
+          <p:nvPr/>
+        </p:nvSpPr>
+        <p:spPr>
+          <a:xfrm>
+            <a:off x="7662671" y="2084832"/>
+            <a:ext cx="640080" cy="658368"/>
+          </a:xfrm>
+          <a:prstGeom prst="rect">
+            <a:avLst/>
+          </a:prstGeom>
+          <a:solidFill>
+            <a:srgbClr val="2E75B6"/>
+          </a:solidFill>
+          <a:ln>
+            <a:noFill/>
+          </a:ln>
+          <a:effectLst/>
+        </p:spPr>
+        <p:style>
+          <a:lnRef idx="1">
+            <a:schemeClr val="accent1"/>
+          </a:lnRef>
+          <a:fillRef idx="3">
+            <a:schemeClr val="accent1"/>
+          </a:fillRef>
+          <a:effectRef idx="2">
+            <a:schemeClr val="accent1"/>
+          </a:effectRef>
+          <a:fontRef idx="minor">
+            <a:schemeClr val="lt1"/>
+          </a:fontRef>
+        </p:style>
+        <p:txBody>
+          <a:bodyPr rtlCol="0" anchor="ctr"/>
+          <a:lstStyle/>
+          <a:p>
+            <a:pPr algn="ctr"/>
+          </a:p>
+        </p:txBody>
+      </p:sp>
+      <p:sp>
+        <p:nvSpPr>
+          <p:cNvPr id="34" name="Rectangle 33"/>
+          <p:cNvSpPr/>
+          <p:nvPr/>
+        </p:nvSpPr>
+        <p:spPr>
+          <a:xfrm>
+            <a:off x="6382512" y="2743200"/>
+            <a:ext cx="2286000" cy="9144"/>
+          </a:xfrm>
+          <a:prstGeom prst="rect">
+            <a:avLst/>
+          </a:prstGeom>
+          <a:solidFill>
+            <a:srgbClr val="7F7F7F"/>
+          </a:solidFill>
+          <a:ln>
+            <a:noFill/>
+          </a:ln>
+          <a:effectLst/>
+        </p:spPr>
+        <p:style>
+          <a:lnRef idx="1">
+            <a:schemeClr val="accent1"/>
+          </a:lnRef>
+          <a:fillRef idx="3">
+            <a:schemeClr val="accent1"/>
+          </a:fillRef>
+          <a:effectRef idx="2">
+            <a:schemeClr val="accent1"/>
+          </a:effectRef>
+          <a:fontRef idx="minor">
+            <a:schemeClr val="lt1"/>
+          </a:fontRef>
+        </p:style>
+        <p:txBody>
+          <a:bodyPr rtlCol="0" anchor="ctr"/>
+          <a:lstStyle/>
+          <a:p>
+            <a:pPr algn="ctr"/>
+          </a:p>
+        </p:txBody>
+      </p:sp>
+      <p:sp>
+        <p:nvSpPr>
+          <p:cNvPr id="35" name="TextBox 34"/>
+          <p:cNvSpPr txBox="1"/>
+          <p:nvPr/>
+        </p:nvSpPr>
+        <p:spPr>
+          <a:xfrm>
+            <a:off x="6382512" y="2468879"/>
+            <a:ext cx="1005840" cy="182880"/>
+          </a:xfrm>
+          <a:prstGeom prst="rect">
+            <a:avLst/>
+          </a:prstGeom>
+          <a:noFill/>
+        </p:spPr>
+        <p:txBody>
+          <a:bodyPr wrap="square" anchor="t" lIns="45720" rIns="45720" tIns="27432" bIns="27432">
+            <a:spAutoFit/>
+          </a:bodyPr>
+          <a:lstStyle/>
+          <a:p>
             <a:pPr algn="ctr">
               <a:spcAft>
-                <a:spcPts val="1400"/>
+                <a:spcPts val="200"/>
               </a:spcAft>
             </a:pPr>
             <a:r>
-              <a:rPr sz="1800" b="0">
+              <a:rPr sz="900" b="1">
                 <a:solidFill>
                   <a:srgbClr val="000000"/>
                 </a:solidFill>
@@ -5554,10 +5727,40 @@
                 <a:ea typeface="맑은 고딕"/>
                 <a:cs typeface="맑은 고딕"/>
               </a:rPr>
-              <a:t>Offloading 하는 경우 vs 안하는 경우 </a:t>
-            </a:r>
-            <a:r>
-              <a:rPr sz="1800" b="1">
+              <a:t>1,850</a:t>
+            </a:r>
+          </a:p>
+        </p:txBody>
+      </p:sp>
+      <p:sp>
+        <p:nvSpPr>
+          <p:cNvPr id="36" name="TextBox 35"/>
+          <p:cNvSpPr txBox="1"/>
+          <p:nvPr/>
+        </p:nvSpPr>
+        <p:spPr>
+          <a:xfrm>
+            <a:off x="7479792" y="1883664"/>
+            <a:ext cx="1005840" cy="182880"/>
+          </a:xfrm>
+          <a:prstGeom prst="rect">
+            <a:avLst/>
+          </a:prstGeom>
+          <a:noFill/>
+        </p:spPr>
+        <p:txBody>
+          <a:bodyPr wrap="square" anchor="t" lIns="45720" rIns="45720" tIns="27432" bIns="27432">
+            <a:spAutoFit/>
+          </a:bodyPr>
+          <a:lstStyle/>
+          <a:p>
+            <a:pPr algn="ctr">
+              <a:spcAft>
+                <a:spcPts val="200"/>
+              </a:spcAft>
+            </a:pPr>
+            <a:r>
+              <a:rPr sz="900" b="1">
                 <a:solidFill>
                   <a:srgbClr val="000000"/>
                 </a:solidFill>
@@ -5565,9 +5768,52 @@
                 <a:ea typeface="맑은 고딕"/>
                 <a:cs typeface="맑은 고딕"/>
               </a:rPr>
-              <a:t>성능 차이</a:t>
-            </a:r>
-          </a:p>
+              <a:t>16,650</a:t>
+            </a:r>
+          </a:p>
+        </p:txBody>
+      </p:sp>
+      <p:sp>
+        <p:nvSpPr>
+          <p:cNvPr id="37" name="Rounded Rectangle 36"/>
+          <p:cNvSpPr/>
+          <p:nvPr/>
+        </p:nvSpPr>
+        <p:spPr>
+          <a:xfrm>
+            <a:off x="8394192" y="2039112"/>
+            <a:ext cx="566928" cy="256032"/>
+          </a:xfrm>
+          <a:prstGeom prst="roundRect">
+            <a:avLst/>
+          </a:prstGeom>
+          <a:solidFill>
+            <a:srgbClr val="FFFFFF"/>
+          </a:solidFill>
+          <a:ln w="15240">
+            <a:solidFill>
+              <a:srgbClr val="FF0000"/>
+            </a:solidFill>
+          </a:ln>
+          <a:effectLst/>
+        </p:spPr>
+        <p:style>
+          <a:lnRef idx="1">
+            <a:schemeClr val="accent1"/>
+          </a:lnRef>
+          <a:fillRef idx="3">
+            <a:schemeClr val="accent1"/>
+          </a:fillRef>
+          <a:effectRef idx="2">
+            <a:schemeClr val="accent1"/>
+          </a:effectRef>
+          <a:fontRef idx="minor">
+            <a:schemeClr val="lt1"/>
+          </a:fontRef>
+        </p:style>
+        <p:txBody>
+          <a:bodyPr rtlCol="0" anchor="ctr" wrap="square" lIns="0" rIns="0" tIns="27432" bIns="27432"/>
+          <a:lstStyle/>
           <a:p>
             <a:pPr algn="ctr">
               <a:spcAft>
@@ -5575,7 +5821,345 @@
               </a:spcAft>
             </a:pPr>
             <a:r>
-              <a:rPr sz="1800" b="1">
+              <a:rPr sz="1000" b="1">
+                <a:solidFill>
+                  <a:srgbClr val="FF0000"/>
+                </a:solidFill>
+                <a:latin typeface="맑은 고딕"/>
+                <a:ea typeface="맑은 고딕"/>
+                <a:cs typeface="맑은 고딕"/>
+              </a:rPr>
+              <a:t>9.0×</a:t>
+            </a:r>
+          </a:p>
+        </p:txBody>
+      </p:sp>
+      <p:sp>
+        <p:nvSpPr>
+          <p:cNvPr id="38" name="TextBox 37"/>
+          <p:cNvSpPr txBox="1"/>
+          <p:nvPr/>
+        </p:nvSpPr>
+        <p:spPr>
+          <a:xfrm>
+            <a:off x="6382512" y="2761488"/>
+            <a:ext cx="1188720" cy="310896"/>
+          </a:xfrm>
+          <a:prstGeom prst="rect">
+            <a:avLst/>
+          </a:prstGeom>
+          <a:noFill/>
+        </p:spPr>
+        <p:txBody>
+          <a:bodyPr wrap="square" anchor="t" lIns="45720" rIns="45720" tIns="27432" bIns="27432">
+            <a:spAutoFit/>
+          </a:bodyPr>
+          <a:lstStyle/>
+          <a:p>
+            <a:pPr algn="ctr">
+              <a:spcAft>
+                <a:spcPts val="200"/>
+              </a:spcAft>
+            </a:pPr>
+            <a:r>
+              <a:rPr sz="750" b="0">
+                <a:solidFill>
+                  <a:srgbClr val="404040"/>
+                </a:solidFill>
+                <a:latin typeface="맑은 고딕"/>
+                <a:ea typeface="맑은 고딕"/>
+                <a:cs typeface="맑은 고딕"/>
+              </a:rPr>
+              <a:t>Baseline
+(offloading 없음)</a:t>
+            </a:r>
+          </a:p>
+        </p:txBody>
+      </p:sp>
+      <p:sp>
+        <p:nvSpPr>
+          <p:cNvPr id="39" name="TextBox 38"/>
+          <p:cNvSpPr txBox="1"/>
+          <p:nvPr/>
+        </p:nvSpPr>
+        <p:spPr>
+          <a:xfrm>
+            <a:off x="7479792" y="2761488"/>
+            <a:ext cx="1188720" cy="310896"/>
+          </a:xfrm>
+          <a:prstGeom prst="rect">
+            <a:avLst/>
+          </a:prstGeom>
+          <a:noFill/>
+        </p:spPr>
+        <p:txBody>
+          <a:bodyPr wrap="square" anchor="t" lIns="45720" rIns="45720" tIns="27432" bIns="27432">
+            <a:spAutoFit/>
+          </a:bodyPr>
+          <a:lstStyle/>
+          <a:p>
+            <a:pPr algn="ctr">
+              <a:spcAft>
+                <a:spcPts val="200"/>
+              </a:spcAft>
+            </a:pPr>
+            <a:r>
+              <a:rPr sz="750" b="1">
+                <a:solidFill>
+                  <a:srgbClr val="404040"/>
+                </a:solidFill>
+                <a:latin typeface="맑은 고딕"/>
+                <a:ea typeface="맑은 고딕"/>
+                <a:cs typeface="맑은 고딕"/>
+              </a:rPr>
+              <a:t>CPU DRAM Offloading</a:t>
+            </a:r>
+          </a:p>
+        </p:txBody>
+      </p:sp>
+      <p:sp>
+        <p:nvSpPr>
+          <p:cNvPr id="40" name="TextBox 39"/>
+          <p:cNvSpPr txBox="1"/>
+          <p:nvPr/>
+        </p:nvSpPr>
+        <p:spPr>
+          <a:xfrm>
+            <a:off x="6291072" y="3072384"/>
+            <a:ext cx="2743200" cy="365760"/>
+          </a:xfrm>
+          <a:prstGeom prst="rect">
+            <a:avLst/>
+          </a:prstGeom>
+          <a:noFill/>
+        </p:spPr>
+        <p:txBody>
+          <a:bodyPr wrap="square" anchor="t" lIns="45720" rIns="45720" tIns="27432" bIns="27432">
+            <a:spAutoFit/>
+          </a:bodyPr>
+          <a:lstStyle/>
+          <a:p>
+            <a:pPr algn="l">
+              <a:spcAft>
+                <a:spcPts val="0"/>
+              </a:spcAft>
+            </a:pPr>
+            <a:r>
+              <a:rPr sz="700" b="0">
+                <a:solidFill>
+                  <a:srgbClr val="595959"/>
+                </a:solidFill>
+                <a:latin typeface="맑은 고딕"/>
+                <a:ea typeface="맑은 고딕"/>
+                <a:cs typeface="맑은 고딕"/>
+              </a:rPr>
+              <a:t>환경: H100 80GB, Llama-3.1-8B-Instruct, CPU DRAM 128GB offload, vLLM native connector (동시성 높은 부하)</a:t>
+            </a:r>
+          </a:p>
+        </p:txBody>
+      </p:sp>
+      <p:sp>
+        <p:nvSpPr>
+          <p:cNvPr id="41" name="TextBox 40"/>
+          <p:cNvSpPr txBox="1"/>
+          <p:nvPr/>
+        </p:nvSpPr>
+        <p:spPr>
+          <a:xfrm>
+            <a:off x="9144000" y="1591056"/>
+            <a:ext cx="2743200" cy="329184"/>
+          </a:xfrm>
+          <a:prstGeom prst="rect">
+            <a:avLst/>
+          </a:prstGeom>
+          <a:noFill/>
+        </p:spPr>
+        <p:txBody>
+          <a:bodyPr wrap="square" anchor="t" lIns="45720" rIns="45720" tIns="27432" bIns="27432">
+            <a:spAutoFit/>
+          </a:bodyPr>
+          <a:lstStyle/>
+          <a:p>
+            <a:pPr algn="l">
+              <a:spcAft>
+                <a:spcPts val="200"/>
+              </a:spcAft>
+            </a:pPr>
+            <a:r>
+              <a:rPr sz="950" b="1">
+                <a:solidFill>
+                  <a:srgbClr val="404040"/>
+                </a:solidFill>
+                <a:latin typeface="맑은 고딕"/>
+                <a:ea typeface="맑은 고딕"/>
+                <a:cs typeface="맑은 고딕"/>
+              </a:rPr>
+              <a:t>② 스케줄링 유무: 처리량 (steps/min) ⑥</a:t>
+            </a:r>
+          </a:p>
+        </p:txBody>
+      </p:sp>
+      <p:sp>
+        <p:nvSpPr>
+          <p:cNvPr id="42" name="Rectangle 41"/>
+          <p:cNvSpPr/>
+          <p:nvPr/>
+        </p:nvSpPr>
+        <p:spPr>
+          <a:xfrm>
+            <a:off x="9418320" y="2375807"/>
+            <a:ext cx="640080" cy="367392"/>
+          </a:xfrm>
+          <a:prstGeom prst="rect">
+            <a:avLst/>
+          </a:prstGeom>
+          <a:solidFill>
+            <a:srgbClr val="7F7F7F"/>
+          </a:solidFill>
+          <a:ln>
+            <a:noFill/>
+          </a:ln>
+          <a:effectLst/>
+        </p:spPr>
+        <p:style>
+          <a:lnRef idx="1">
+            <a:schemeClr val="accent1"/>
+          </a:lnRef>
+          <a:fillRef idx="3">
+            <a:schemeClr val="accent1"/>
+          </a:fillRef>
+          <a:effectRef idx="2">
+            <a:schemeClr val="accent1"/>
+          </a:effectRef>
+          <a:fontRef idx="minor">
+            <a:schemeClr val="lt1"/>
+          </a:fontRef>
+        </p:style>
+        <p:txBody>
+          <a:bodyPr rtlCol="0" anchor="ctr"/>
+          <a:lstStyle/>
+          <a:p>
+            <a:pPr algn="ctr"/>
+          </a:p>
+        </p:txBody>
+      </p:sp>
+      <p:sp>
+        <p:nvSpPr>
+          <p:cNvPr id="43" name="Rectangle 42"/>
+          <p:cNvSpPr/>
+          <p:nvPr/>
+        </p:nvSpPr>
+        <p:spPr>
+          <a:xfrm>
+            <a:off x="10515600" y="2084832"/>
+            <a:ext cx="640080" cy="658368"/>
+          </a:xfrm>
+          <a:prstGeom prst="rect">
+            <a:avLst/>
+          </a:prstGeom>
+          <a:solidFill>
+            <a:srgbClr val="C55A11"/>
+          </a:solidFill>
+          <a:ln>
+            <a:noFill/>
+          </a:ln>
+          <a:effectLst/>
+        </p:spPr>
+        <p:style>
+          <a:lnRef idx="1">
+            <a:schemeClr val="accent1"/>
+          </a:lnRef>
+          <a:fillRef idx="3">
+            <a:schemeClr val="accent1"/>
+          </a:fillRef>
+          <a:effectRef idx="2">
+            <a:schemeClr val="accent1"/>
+          </a:effectRef>
+          <a:fontRef idx="minor">
+            <a:schemeClr val="lt1"/>
+          </a:fontRef>
+        </p:style>
+        <p:txBody>
+          <a:bodyPr rtlCol="0" anchor="ctr"/>
+          <a:lstStyle/>
+          <a:p>
+            <a:pPr algn="ctr"/>
+          </a:p>
+        </p:txBody>
+      </p:sp>
+      <p:sp>
+        <p:nvSpPr>
+          <p:cNvPr id="44" name="Rectangle 43"/>
+          <p:cNvSpPr/>
+          <p:nvPr/>
+        </p:nvSpPr>
+        <p:spPr>
+          <a:xfrm>
+            <a:off x="9235440" y="2743200"/>
+            <a:ext cx="2286000" cy="9144"/>
+          </a:xfrm>
+          <a:prstGeom prst="rect">
+            <a:avLst/>
+          </a:prstGeom>
+          <a:solidFill>
+            <a:srgbClr val="7F7F7F"/>
+          </a:solidFill>
+          <a:ln>
+            <a:noFill/>
+          </a:ln>
+          <a:effectLst/>
+        </p:spPr>
+        <p:style>
+          <a:lnRef idx="1">
+            <a:schemeClr val="accent1"/>
+          </a:lnRef>
+          <a:fillRef idx="3">
+            <a:schemeClr val="accent1"/>
+          </a:fillRef>
+          <a:effectRef idx="2">
+            <a:schemeClr val="accent1"/>
+          </a:effectRef>
+          <a:fontRef idx="minor">
+            <a:schemeClr val="lt1"/>
+          </a:fontRef>
+        </p:style>
+        <p:txBody>
+          <a:bodyPr rtlCol="0" anchor="ctr"/>
+          <a:lstStyle/>
+          <a:p>
+            <a:pPr algn="ctr"/>
+          </a:p>
+        </p:txBody>
+      </p:sp>
+      <p:sp>
+        <p:nvSpPr>
+          <p:cNvPr id="45" name="TextBox 44"/>
+          <p:cNvSpPr txBox="1"/>
+          <p:nvPr/>
+        </p:nvSpPr>
+        <p:spPr>
+          <a:xfrm>
+            <a:off x="9235440" y="2174639"/>
+            <a:ext cx="1005840" cy="182880"/>
+          </a:xfrm>
+          <a:prstGeom prst="rect">
+            <a:avLst/>
+          </a:prstGeom>
+          <a:noFill/>
+        </p:spPr>
+        <p:txBody>
+          <a:bodyPr wrap="square" anchor="t" lIns="45720" rIns="45720" tIns="27432" bIns="27432">
+            <a:spAutoFit/>
+          </a:bodyPr>
+          <a:lstStyle/>
+          <a:p>
+            <a:pPr algn="ctr">
+              <a:spcAft>
+                <a:spcPts val="200"/>
+              </a:spcAft>
+            </a:pPr>
+            <a:r>
+              <a:rPr sz="900" b="1">
                 <a:solidFill>
                   <a:srgbClr val="000000"/>
                 </a:solidFill>
@@ -5583,14 +6167,285 @@
                 <a:ea typeface="맑은 고딕"/>
                 <a:cs typeface="맑은 고딕"/>
               </a:rPr>
-              <a:t>스케줄링 하는 경우 vs 안하는 경우 성능 차이</a:t>
-            </a:r>
-          </a:p>
-        </p:txBody>
-      </p:sp>
-      <p:sp>
-        <p:nvSpPr>
-          <p:cNvPr id="32" name="Rectangle 31"/>
+              <a:t>375</a:t>
+            </a:r>
+          </a:p>
+        </p:txBody>
+      </p:sp>
+      <p:sp>
+        <p:nvSpPr>
+          <p:cNvPr id="46" name="TextBox 45"/>
+          <p:cNvSpPr txBox="1"/>
+          <p:nvPr/>
+        </p:nvSpPr>
+        <p:spPr>
+          <a:xfrm>
+            <a:off x="10332720" y="1883664"/>
+            <a:ext cx="1005840" cy="182880"/>
+          </a:xfrm>
+          <a:prstGeom prst="rect">
+            <a:avLst/>
+          </a:prstGeom>
+          <a:noFill/>
+        </p:spPr>
+        <p:txBody>
+          <a:bodyPr wrap="square" anchor="t" lIns="45720" rIns="45720" tIns="27432" bIns="27432">
+            <a:spAutoFit/>
+          </a:bodyPr>
+          <a:lstStyle/>
+          <a:p>
+            <a:pPr algn="ctr">
+              <a:spcAft>
+                <a:spcPts val="200"/>
+              </a:spcAft>
+            </a:pPr>
+            <a:r>
+              <a:rPr sz="900" b="1">
+                <a:solidFill>
+                  <a:srgbClr val="000000"/>
+                </a:solidFill>
+                <a:latin typeface="맑은 고딕"/>
+                <a:ea typeface="맑은 고딕"/>
+                <a:cs typeface="맑은 고딕"/>
+              </a:rPr>
+              <a:t>672</a:t>
+            </a:r>
+          </a:p>
+        </p:txBody>
+      </p:sp>
+      <p:sp>
+        <p:nvSpPr>
+          <p:cNvPr id="47" name="Rounded Rectangle 46"/>
+          <p:cNvSpPr/>
+          <p:nvPr/>
+        </p:nvSpPr>
+        <p:spPr>
+          <a:xfrm>
+            <a:off x="11247120" y="2039112"/>
+            <a:ext cx="566928" cy="256032"/>
+          </a:xfrm>
+          <a:prstGeom prst="roundRect">
+            <a:avLst/>
+          </a:prstGeom>
+          <a:solidFill>
+            <a:srgbClr val="FFFFFF"/>
+          </a:solidFill>
+          <a:ln w="15240">
+            <a:solidFill>
+              <a:srgbClr val="FF0000"/>
+            </a:solidFill>
+          </a:ln>
+          <a:effectLst/>
+        </p:spPr>
+        <p:style>
+          <a:lnRef idx="1">
+            <a:schemeClr val="accent1"/>
+          </a:lnRef>
+          <a:fillRef idx="3">
+            <a:schemeClr val="accent1"/>
+          </a:fillRef>
+          <a:effectRef idx="2">
+            <a:schemeClr val="accent1"/>
+          </a:effectRef>
+          <a:fontRef idx="minor">
+            <a:schemeClr val="lt1"/>
+          </a:fontRef>
+        </p:style>
+        <p:txBody>
+          <a:bodyPr rtlCol="0" anchor="ctr" wrap="square" lIns="0" rIns="0" tIns="27432" bIns="27432"/>
+          <a:lstStyle/>
+          <a:p>
+            <a:pPr algn="ctr">
+              <a:spcAft>
+                <a:spcPts val="200"/>
+              </a:spcAft>
+            </a:pPr>
+            <a:r>
+              <a:rPr sz="1000" b="1">
+                <a:solidFill>
+                  <a:srgbClr val="FF0000"/>
+                </a:solidFill>
+                <a:latin typeface="맑은 고딕"/>
+                <a:ea typeface="맑은 고딕"/>
+                <a:cs typeface="맑은 고딕"/>
+              </a:rPr>
+              <a:t>1.79×</a:t>
+            </a:r>
+          </a:p>
+        </p:txBody>
+      </p:sp>
+      <p:sp>
+        <p:nvSpPr>
+          <p:cNvPr id="48" name="TextBox 47"/>
+          <p:cNvSpPr txBox="1"/>
+          <p:nvPr/>
+        </p:nvSpPr>
+        <p:spPr>
+          <a:xfrm>
+            <a:off x="9235440" y="2761488"/>
+            <a:ext cx="1188720" cy="310896"/>
+          </a:xfrm>
+          <a:prstGeom prst="rect">
+            <a:avLst/>
+          </a:prstGeom>
+          <a:noFill/>
+        </p:spPr>
+        <p:txBody>
+          <a:bodyPr wrap="square" anchor="t" lIns="45720" rIns="45720" tIns="27432" bIns="27432">
+            <a:spAutoFit/>
+          </a:bodyPr>
+          <a:lstStyle/>
+          <a:p>
+            <a:pPr algn="ctr">
+              <a:spcAft>
+                <a:spcPts val="200"/>
+              </a:spcAft>
+            </a:pPr>
+            <a:r>
+              <a:rPr sz="750" b="0">
+                <a:solidFill>
+                  <a:srgbClr val="404040"/>
+                </a:solidFill>
+                <a:latin typeface="맑은 고딕"/>
+                <a:ea typeface="맑은 고딕"/>
+                <a:cs typeface="맑은 고딕"/>
+              </a:rPr>
+              <a:t>Baseline
+(vLLM 요청 단위)</a:t>
+            </a:r>
+          </a:p>
+        </p:txBody>
+      </p:sp>
+      <p:sp>
+        <p:nvSpPr>
+          <p:cNvPr id="49" name="TextBox 48"/>
+          <p:cNvSpPr txBox="1"/>
+          <p:nvPr/>
+        </p:nvSpPr>
+        <p:spPr>
+          <a:xfrm>
+            <a:off x="10332720" y="2761488"/>
+            <a:ext cx="1188720" cy="310896"/>
+          </a:xfrm>
+          <a:prstGeom prst="rect">
+            <a:avLst/>
+          </a:prstGeom>
+          <a:noFill/>
+        </p:spPr>
+        <p:txBody>
+          <a:bodyPr wrap="square" anchor="t" lIns="45720" rIns="45720" tIns="27432" bIns="27432">
+            <a:spAutoFit/>
+          </a:bodyPr>
+          <a:lstStyle/>
+          <a:p>
+            <a:pPr algn="ctr">
+              <a:spcAft>
+                <a:spcPts val="200"/>
+              </a:spcAft>
+            </a:pPr>
+            <a:r>
+              <a:rPr sz="750" b="1">
+                <a:solidFill>
+                  <a:srgbClr val="404040"/>
+                </a:solidFill>
+                <a:latin typeface="맑은 고딕"/>
+                <a:ea typeface="맑은 고딕"/>
+                <a:cs typeface="맑은 고딕"/>
+              </a:rPr>
+              <a:t>ThunderAgent
+(프로그램 인지)</a:t>
+            </a:r>
+          </a:p>
+        </p:txBody>
+      </p:sp>
+      <p:sp>
+        <p:nvSpPr>
+          <p:cNvPr id="50" name="TextBox 49"/>
+          <p:cNvSpPr txBox="1"/>
+          <p:nvPr/>
+        </p:nvSpPr>
+        <p:spPr>
+          <a:xfrm>
+            <a:off x="9144000" y="3072384"/>
+            <a:ext cx="2743200" cy="365760"/>
+          </a:xfrm>
+          <a:prstGeom prst="rect">
+            <a:avLst/>
+          </a:prstGeom>
+          <a:noFill/>
+        </p:spPr>
+        <p:txBody>
+          <a:bodyPr wrap="square" anchor="t" lIns="45720" rIns="45720" tIns="27432" bIns="27432">
+            <a:spAutoFit/>
+          </a:bodyPr>
+          <a:lstStyle/>
+          <a:p>
+            <a:pPr algn="l">
+              <a:spcAft>
+                <a:spcPts val="0"/>
+              </a:spcAft>
+            </a:pPr>
+            <a:r>
+              <a:rPr sz="700" b="0">
+                <a:solidFill>
+                  <a:srgbClr val="595959"/>
+                </a:solidFill>
+                <a:latin typeface="맑은 고딕"/>
+                <a:ea typeface="맑은 고딕"/>
+                <a:cs typeface="맑은 고딕"/>
+              </a:rPr>
+              <a:t>환경: H100 2노드, GLM-4.5-fp8, mini-SWE-agent, 동시 144 programs (벤치마크 전반 1.48–3.58×)</a:t>
+            </a:r>
+          </a:p>
+        </p:txBody>
+      </p:sp>
+      <p:sp>
+        <p:nvSpPr>
+          <p:cNvPr id="51" name="Rectangle 50"/>
+          <p:cNvSpPr/>
+          <p:nvPr/>
+        </p:nvSpPr>
+        <p:spPr>
+          <a:xfrm>
+            <a:off x="9098280" y="1645920"/>
+            <a:ext cx="9144" cy="1755648"/>
+          </a:xfrm>
+          <a:prstGeom prst="rect">
+            <a:avLst/>
+          </a:prstGeom>
+          <a:solidFill>
+            <a:srgbClr val="BFBFBF"/>
+          </a:solidFill>
+          <a:ln>
+            <a:noFill/>
+          </a:ln>
+          <a:effectLst/>
+        </p:spPr>
+        <p:style>
+          <a:lnRef idx="1">
+            <a:schemeClr val="accent1"/>
+          </a:lnRef>
+          <a:fillRef idx="3">
+            <a:schemeClr val="accent1"/>
+          </a:fillRef>
+          <a:effectRef idx="2">
+            <a:schemeClr val="accent1"/>
+          </a:effectRef>
+          <a:fontRef idx="minor">
+            <a:schemeClr val="lt1"/>
+          </a:fontRef>
+        </p:style>
+        <p:txBody>
+          <a:bodyPr rtlCol="0" anchor="ctr"/>
+          <a:lstStyle/>
+          <a:p>
+            <a:pPr algn="ctr"/>
+          </a:p>
+        </p:txBody>
+      </p:sp>
+      <p:sp>
+        <p:nvSpPr>
+          <p:cNvPr id="52" name="Rectangle 51"/>
           <p:cNvSpPr/>
           <p:nvPr/>
         </p:nvSpPr>
@@ -5635,7 +6490,7 @@
       </p:sp>
       <p:sp>
         <p:nvSpPr>
-          <p:cNvPr id="33" name="Rectangle 32"/>
+          <p:cNvPr id="53" name="Rectangle 52"/>
           <p:cNvSpPr/>
           <p:nvPr/>
         </p:nvSpPr>
@@ -5694,7 +6549,7 @@
       </p:sp>
       <p:sp>
         <p:nvSpPr>
-          <p:cNvPr id="34" name="TextBox 33"/>
+          <p:cNvPr id="54" name="TextBox 53"/>
           <p:cNvSpPr txBox="1"/>
           <p:nvPr/>
         </p:nvSpPr>
@@ -5735,7 +6590,7 @@
       </p:sp>
       <p:graphicFrame>
         <p:nvGraphicFramePr>
-          <p:cNvPr id="35" name="Table 34"/>
+          <p:cNvPr id="55" name="Table 54"/>
           <p:cNvGraphicFramePr>
             <a:graphicFrameLocks noGrp="1"/>
           </p:cNvGraphicFramePr>
@@ -6753,7 +7608,7 @@
       </p:graphicFrame>
       <p:sp>
         <p:nvSpPr>
-          <p:cNvPr id="36" name="Rectangle 35"/>
+          <p:cNvPr id="56" name="Rectangle 55"/>
           <p:cNvSpPr/>
           <p:nvPr/>
         </p:nvSpPr>
@@ -6798,7 +7653,7 @@
       </p:sp>
       <p:sp>
         <p:nvSpPr>
-          <p:cNvPr id="37" name="Rectangle 36"/>
+          <p:cNvPr id="57" name="Rectangle 56"/>
           <p:cNvSpPr/>
           <p:nvPr/>
         </p:nvSpPr>
@@ -6857,7 +7712,7 @@
       </p:sp>
       <p:sp>
         <p:nvSpPr>
-          <p:cNvPr id="38" name="TextBox 37"/>
+          <p:cNvPr id="58" name="TextBox 57"/>
           <p:cNvSpPr txBox="1"/>
           <p:nvPr/>
         </p:nvSpPr>
@@ -6898,7 +7753,7 @@
       </p:sp>
       <p:sp>
         <p:nvSpPr>
-          <p:cNvPr id="39" name="Rectangle 38"/>
+          <p:cNvPr id="59" name="Rectangle 58"/>
           <p:cNvSpPr/>
           <p:nvPr/>
         </p:nvSpPr>
@@ -6959,7 +7814,7 @@
       </p:sp>
       <p:cxnSp>
         <p:nvCxnSpPr>
-          <p:cNvPr id="40" name="Connector 39"/>
+          <p:cNvPr id="60" name="Connector 59"/>
           <p:cNvCxnSpPr/>
           <p:nvPr/>
         </p:nvCxnSpPr>
@@ -6996,7 +7851,7 @@
       </p:cxnSp>
       <p:sp>
         <p:nvSpPr>
-          <p:cNvPr id="41" name="Rectangle 40"/>
+          <p:cNvPr id="61" name="Rectangle 60"/>
           <p:cNvSpPr/>
           <p:nvPr/>
         </p:nvSpPr>
@@ -7076,7 +7931,7 @@
       </p:sp>
       <p:cxnSp>
         <p:nvCxnSpPr>
-          <p:cNvPr id="42" name="Connector 41"/>
+          <p:cNvPr id="62" name="Connector 61"/>
           <p:cNvCxnSpPr/>
           <p:nvPr/>
         </p:nvCxnSpPr>
@@ -7114,7 +7969,7 @@
       </p:cxnSp>
       <p:sp>
         <p:nvSpPr>
-          <p:cNvPr id="43" name="Rectangle 42"/>
+          <p:cNvPr id="63" name="Rectangle 62"/>
           <p:cNvSpPr/>
           <p:nvPr/>
         </p:nvSpPr>
@@ -7175,7 +8030,7 @@
       </p:sp>
       <p:sp>
         <p:nvSpPr>
-          <p:cNvPr id="44" name="Rectangle 43"/>
+          <p:cNvPr id="64" name="Rectangle 63"/>
           <p:cNvSpPr/>
           <p:nvPr/>
         </p:nvSpPr>
@@ -7236,7 +8091,7 @@
       </p:sp>
       <p:sp>
         <p:nvSpPr>
-          <p:cNvPr id="45" name="Rectangle 44"/>
+          <p:cNvPr id="65" name="Rectangle 64"/>
           <p:cNvSpPr/>
           <p:nvPr/>
         </p:nvSpPr>
@@ -7297,7 +8152,7 @@
       </p:sp>
       <p:sp>
         <p:nvSpPr>
-          <p:cNvPr id="46" name="Rectangle 45"/>
+          <p:cNvPr id="66" name="Rectangle 65"/>
           <p:cNvSpPr/>
           <p:nvPr/>
         </p:nvSpPr>
@@ -7359,7 +8214,7 @@
       </p:sp>
       <p:sp>
         <p:nvSpPr>
-          <p:cNvPr id="47" name="Rectangle 46"/>
+          <p:cNvPr id="67" name="Rectangle 66"/>
           <p:cNvSpPr/>
           <p:nvPr/>
         </p:nvSpPr>
@@ -7421,7 +8276,7 @@
       </p:sp>
       <p:sp>
         <p:nvSpPr>
-          <p:cNvPr id="48" name="Rectangle 47"/>
+          <p:cNvPr id="68" name="Rectangle 67"/>
           <p:cNvSpPr/>
           <p:nvPr/>
         </p:nvSpPr>
@@ -7483,7 +8338,7 @@
       </p:sp>
       <p:sp>
         <p:nvSpPr>
-          <p:cNvPr id="49" name="TextBox 48"/>
+          <p:cNvPr id="69" name="TextBox 68"/>
           <p:cNvSpPr txBox="1"/>
           <p:nvPr/>
         </p:nvSpPr>
@@ -7524,7 +8379,7 @@
       </p:sp>
       <p:sp>
         <p:nvSpPr>
-          <p:cNvPr id="50" name="TextBox 49"/>
+          <p:cNvPr id="70" name="TextBox 69"/>
           <p:cNvSpPr txBox="1"/>
           <p:nvPr/>
         </p:nvSpPr>
@@ -7565,7 +8420,7 @@
       </p:sp>
       <p:sp>
         <p:nvSpPr>
-          <p:cNvPr id="51" name="Rounded Rectangle 50"/>
+          <p:cNvPr id="71" name="Rounded Rectangle 70"/>
           <p:cNvSpPr/>
           <p:nvPr/>
         </p:nvSpPr>
@@ -7624,7 +8479,7 @@
       </p:sp>
       <p:sp>
         <p:nvSpPr>
-          <p:cNvPr id="52" name="TextBox 51"/>
+          <p:cNvPr id="72" name="TextBox 71"/>
           <p:cNvSpPr txBox="1"/>
           <p:nvPr/>
         </p:nvSpPr>
@@ -7643,6 +8498,24 @@
             <a:spAutoFit/>
           </a:bodyPr>
           <a:lstStyle/>
+          <a:p>
+            <a:pPr algn="l">
+              <a:spcAft>
+                <a:spcPts val="0"/>
+              </a:spcAft>
+            </a:pPr>
+            <a:r>
+              <a:rPr sz="650" b="0">
+                <a:solidFill>
+                  <a:srgbClr val="595959"/>
+                </a:solidFill>
+                <a:latin typeface="맑은 고딕"/>
+                <a:ea typeface="맑은 고딕"/>
+                <a:cs typeface="맑은 고딕"/>
+              </a:rPr>
+              <a:t>⑤ vLLM Blog, Inside vLLM's New KV Offloading Connector (2026-01-08): 처리량 최대 9×, 수치·환경은 3rd-party 요약(barrahome.org) 기준  ⑥ ThunderAgent, arXiv:2602.13692 부록 ablation(1.79×), 환경은 검색 요약 기준. ⑤⑥ 모두 원문 대조 전</a:t>
+            </a:r>
+          </a:p>
           <a:p>
             <a:pPr algn="l">
               <a:spcAft>

</xml_diff>